<commit_message>
Fix announcing sentences that did not match their lists; add LSA Geography of Cameroon lessons 1-10
- Every board-summary intro now names exactly what follows (e.g. "The location and
  characteristics of ... are the following:" instead of "... has the following
  characteristics:" followed by Location), in F1, F2, F3, F4, F5, F2T and LSA.
- Definitions no longer appear inside lists (ecosystem, domesticated landscape).
- An announcing sentence is never left alone on a slide.
- New folder lecons/LSA/Geography of Cameroon: lessons 1-10 (relief, climate, soils,
  vegetation, drainage, population, urbanisation, agriculture, forests, minerals and
  energy), based on the teacher's course notes with checked figures.

Co-Authored-By: Claude Opus 5.5 <noreply@anthropic.com>
Claude-Session: https://claude.ai/code/session_0115LFSb2ktGLWPeVksFkSer
</commit_message>
<xml_diff>
--- a/lecons/F1/03_F1_M1_PW01_Representation_of_the_Earth_s_Shape_and_Size.pptx
+++ b/lecons/F1/03_F1_M1_PW01_Representation_of_the_Earth_s_Shape_and_Size.pptx
@@ -4169,7 +4169,7 @@
           <a:p>
             <a:r>
               <a:rPr lang="en-US" dirty="0"/>
-              <a:t>Let us copy Reading the Scale and Calculating Distances. We calculate a real distance in the following steps. On this slide we have Step 1 and Step 2. Write each point on a new line, with the key term first, and explain it in your own words when we revise. When you finish, we go to the next slide.</a:t>
+              <a:t>Let us copy Reading the Scale and Calculating Distances. We calculate a real distance as follows. On this slide we have Step 1, Step 2 and Step 3. Write each point on a new line, with the key term first, and explain it in your own words when we revise. When you finish, we go to the next slide.</a:t>
             </a:r>
             <a:endParaRPr lang="en-US" dirty="0"/>
           </a:p>
@@ -4257,7 +4257,7 @@
           <a:p>
             <a:r>
               <a:rPr lang="en-US" dirty="0"/>
-              <a:t>We continue with Reading the Scale and Calculating Distances. On this slide we have Step 3 and Example. Write each point on a new line, with the key term first, and explain it in your own words when we revise.</a:t>
+              <a:t>We continue with Reading the Scale and Calculating Distances. On this slide we have Example. Write each point on a new line, with the key term first, and explain it in your own words when we revise.</a:t>
             </a:r>
             <a:endParaRPr lang="en-US" dirty="0"/>
           </a:p>
@@ -17634,7 +17634,7 @@
         <p:spPr>
           <a:xfrm>
             <a:off x="0" y="658368"/>
-            <a:ext cx="2468880" cy="5833872"/>
+            <a:ext cx="1463040" cy="5833872"/>
           </a:xfrm>
           <a:prstGeom prst="rect">
             <a:avLst/>
@@ -17649,8 +17649,8 @@
         </p:nvSpPr>
         <p:spPr>
           <a:xfrm>
-            <a:off x="2697480" y="1005840"/>
-            <a:ext cx="9174175" cy="731520"/>
+            <a:off x="1691640" y="1005840"/>
+            <a:ext cx="10180015" cy="731520"/>
           </a:xfrm>
           <a:prstGeom prst="rect">
             <a:avLst/>
@@ -17690,8 +17690,8 @@
         </p:nvSpPr>
         <p:spPr>
           <a:xfrm>
-            <a:off x="2697480" y="1783080"/>
-            <a:ext cx="9174175" cy="4663440"/>
+            <a:off x="1691640" y="1783080"/>
+            <a:ext cx="10180015" cy="4663440"/>
           </a:xfrm>
           <a:prstGeom prst="rect">
             <a:avLst/>
@@ -17718,7 +17718,7 @@
                 <a:ea typeface="Times New Roman" pitchFamily="34" charset="-122"/>
                 <a:cs typeface="Times New Roman" pitchFamily="34" charset="-120"/>
               </a:rPr>
-              <a:t>We calculate a real distance in the following steps:</a:t>
+              <a:t>We calculate a real distance as follows:</a:t>
             </a:r>
             <a:endParaRPr lang="en-US" sz="4000" dirty="0"/>
           </a:p>
@@ -17793,6 +17793,43 @@
                 <a:cs typeface="Times New Roman" pitchFamily="34" charset="-120"/>
               </a:rPr>
               <a:t>We multiply the map distance by the value of the scale.</a:t>
+            </a:r>
+            <a:endParaRPr lang="en-US" sz="4000" dirty="0"/>
+          </a:p>
+          <a:p>
+            <a:pPr algn="l" indent="0" marL="0">
+              <a:spcAft>
+                <a:spcPts val="800"/>
+              </a:spcAft>
+              <a:buNone/>
+            </a:pPr>
+            <a:r>
+              <a:rPr lang="en-US" sz="4000" b="1" dirty="0">
+                <a:solidFill>
+                  <a:srgbClr val="111111"/>
+                </a:solidFill>
+                <a:latin typeface="Times New Roman" pitchFamily="34" charset="0"/>
+                <a:ea typeface="Times New Roman" pitchFamily="34" charset="-122"/>
+                <a:cs typeface="Times New Roman" pitchFamily="34" charset="-120"/>
+              </a:rPr>
+              <a:t>Step 3: </a:t>
+            </a:r>
+            <a:pPr algn="l" indent="0" marL="0">
+              <a:spcAft>
+                <a:spcPts val="800"/>
+              </a:spcAft>
+              <a:buNone/>
+            </a:pPr>
+            <a:r>
+              <a:rPr lang="en-US" sz="4000" dirty="0">
+                <a:solidFill>
+                  <a:srgbClr val="111111"/>
+                </a:solidFill>
+                <a:latin typeface="Times New Roman" pitchFamily="34" charset="0"/>
+                <a:ea typeface="Times New Roman" pitchFamily="34" charset="-122"/>
+                <a:cs typeface="Times New Roman" pitchFamily="34" charset="-120"/>
+              </a:rPr>
+              <a:t>We write the answer in kilometres.</a:t>
             </a:r>
             <a:endParaRPr lang="en-US" sz="4000" dirty="0"/>
           </a:p>
@@ -17995,43 +18032,6 @@
         <p:txBody>
           <a:bodyPr wrap="square" lIns="0" tIns="0" rIns="0" bIns="0" rtlCol="0" anchor="t"/>
           <a:lstStyle/>
-          <a:p>
-            <a:pPr algn="l" indent="0" marL="0">
-              <a:spcAft>
-                <a:spcPts val="800"/>
-              </a:spcAft>
-              <a:buNone/>
-            </a:pPr>
-            <a:r>
-              <a:rPr lang="en-US" sz="4000" b="1" dirty="0">
-                <a:solidFill>
-                  <a:srgbClr val="111111"/>
-                </a:solidFill>
-                <a:latin typeface="Times New Roman" pitchFamily="34" charset="0"/>
-                <a:ea typeface="Times New Roman" pitchFamily="34" charset="-122"/>
-                <a:cs typeface="Times New Roman" pitchFamily="34" charset="-120"/>
-              </a:rPr>
-              <a:t>Step 3: </a:t>
-            </a:r>
-            <a:pPr algn="l" indent="0" marL="0">
-              <a:spcAft>
-                <a:spcPts val="800"/>
-              </a:spcAft>
-              <a:buNone/>
-            </a:pPr>
-            <a:r>
-              <a:rPr lang="en-US" sz="4000" dirty="0">
-                <a:solidFill>
-                  <a:srgbClr val="111111"/>
-                </a:solidFill>
-                <a:latin typeface="Times New Roman" pitchFamily="34" charset="0"/>
-                <a:ea typeface="Times New Roman" pitchFamily="34" charset="-122"/>
-                <a:cs typeface="Times New Roman" pitchFamily="34" charset="-120"/>
-              </a:rPr>
-              <a:t>We write the answer in kilometres.</a:t>
-            </a:r>
-            <a:endParaRPr lang="en-US" sz="4000" dirty="0"/>
-          </a:p>
           <a:p>
             <a:pPr algn="l" indent="0" marL="0">
               <a:spcAft>

</xml_diff>